<commit_message>
docs: PPTX completeness audit + 8 new slides covering all gaps
Audit identified 5 unused figures + 4 newly-added report sections
not reflected in slides. Surgical additions made:

Deck 1 (15→16): +S13 §7.7 statistical pattern comparison
  (Kruskal-Wallis H=17.42 p<0.01, Fisher p=0.018, Spearman, industry FE)

Deck 3 (15→17): +S14 fig_gir_timeseries baseline,
  +S15 fig_satellite_scatter 4-channel cross-validation

Deck 4 (15→17): +S14 fig_gir_heatmap firm×year overview,
  +S15 fig_case_studies 4 industrial-site comparison

Deck 5 (12→15): +S11 §10.6 international (CBAM/Japan/EPA/IFRS),
  +S12 §10.7 stakeholder Q&A 5 groups,
  +S13 §11.4 10-year roadmap Phase 1-5 (2026-2035)

Total: 67 → 75 slides. Figure utilization 21/26 → 25/26 (96%).
Report-to-PPT section coverage: 100% (no gaps remaining).

Audit memo: report/audit_pptx_completeness.md documents the
complete figure-by-figure and section-by-section mapping table.

Co-Authored-By: Claude Opus 4.7 (1M context) <noreply@anthropic.com>
</commit_message>
<xml_diff>
--- a/report/decks/01_KeyFindings.pptx
+++ b/report/decks/01_KeyFindings.pptx
@@ -20,6 +20,7 @@
     <p:sldId id="268" r:id="rId19"/>
     <p:sldId id="269" r:id="rId20"/>
     <p:sldId id="270" r:id="rId21"/>
+    <p:sldId id="271" r:id="rId22"/>
   </p:sldIdLst>
   <p:sldSz cx="12188952" cy="6858000" type="screen4x3"/>
   <p:notesSz cx="6858000" cy="9144000"/>
@@ -3315,7 +3316,7 @@
                   <a:srgbClr val="9CA3AF"/>
                 </a:solidFill>
               </a:rPr>
-              <a:t>2026 AX 아이디어 경진대회 · 자유분석 부문 · 15장 · github.com/zxsa0716/AX_Contest</a:t>
+              <a:t>2026 AX 아이디어 경진대회 · 자유분석 부문 · 16장 · github.com/zxsa0716/AX_Contest</a:t>
             </a:r>
           </a:p>
         </p:txBody>
@@ -3688,7 +3689,7 @@
                   <a:srgbClr val="9CA3AF"/>
                 </a:solidFill>
               </a:rPr>
-              <a:t>10 / 15</a:t>
+              <a:t>10 / 16</a:t>
             </a:r>
           </a:p>
         </p:txBody>
@@ -3983,7 +3984,7 @@
                   <a:srgbClr val="9CA3AF"/>
                 </a:solidFill>
               </a:rPr>
-              <a:t>11 / 15</a:t>
+              <a:t>11 / 16</a:t>
             </a:r>
           </a:p>
         </p:txBody>
@@ -4371,7 +4372,7 @@
                   <a:srgbClr val="9CA3AF"/>
                 </a:solidFill>
               </a:rPr>
-              <a:t>12 / 15</a:t>
+              <a:t>12 / 16</a:t>
             </a:r>
           </a:p>
         </p:txBody>
@@ -4465,7 +4466,7 @@
                   <a:srgbClr val="1F2937"/>
                 </a:solidFill>
               </a:rPr>
-              <a:t>방법론 강건성 — 8단계 모두 학술 표준 준수</a:t>
+              <a:t>패턴군 통계적 비교 — 분류 신뢰성 정량화</a:t>
             </a:r>
           </a:p>
         </p:txBody>
@@ -4546,7 +4547,7 @@
                   <a:srgbClr val="4B5563"/>
                 </a:solidFill>
               </a:rPr>
-              <a:t>본 연구의 핵심 발견은 단일 방법에 의존하지 않으며 8단계 파이프라인 전반에 걸친 다중 robustness 검증을 통과했다.</a:t>
+              <a:t>본 연구의 패턴 분류가 우연한 잡음이 아닌 통계적으로 유의한 신호임을 다음 세 검정으로 정량화했다.</a:t>
             </a:r>
           </a:p>
           <a:p>
@@ -4556,12 +4557,12 @@
               </a:spcAft>
             </a:pPr>
             <a:r>
-              <a:rPr sz="1300">
-                <a:solidFill>
-                  <a:srgbClr val="4B5563"/>
-                </a:solidFill>
-              </a:rPr>
-              <a:t>ERA5 기상보정에서 NO₂ R²=0.76, HCHO R²=0.94 수준의 설명력으로 기상 효과를 제거했으며, MERRA-2 독립 재분석으로 sensitivity check를 수행했다. ASOS 5개 지점 지상 관측으로 ERA5 격자 모델을 검증했다. 패턴 분류는 ERA5 보정 전후 모두에서 동일한 결과(D 패턴 2개사)를 산출했다.</a:t>
+              <a:rPr sz="1400" b="1">
+                <a:solidFill>
+                  <a:srgbClr val="1E3A8A"/>
+                </a:solidFill>
+              </a:rPr>
+              <a:t>Kruskal-Wallis H 검정 — 패턴군별 priority_score 분포 차이</a:t>
             </a:r>
           </a:p>
           <a:p>
@@ -4576,7 +4577,7 @@
                   <a:srgbClr val="4B5563"/>
                 </a:solidFill>
               </a:rPr>
-              <a:t>이상탐지 contamination 파라미터를 0.05~0.20으로 sweep한 결과 핵심 발견은 모든 임계값에서 일관됐다. Heckman 회귀의 모든 계수는 Bootstrap B=2000 firm-block CI로 보고되어 소표본 불확실성이 정량화됐다. 표본 선택편향은 IMR 통제로 명시적으로 다뤘다.</a:t>
+              <a:t>23개사를 5개 패턴(A↑, A↓, mixed, C, D)으로 분류한 뒤 priority_score 분포 차이를 비모수 Kruskal-Wallis H로 검정한 결과, **H = 17.42, df = 4, p &lt; 0.01**로 패턴 간 분포 차이가 유의했다. 사후 Dunn-Bonferroni 다중비교에서 패턴 D(평균 0.46)는 패턴 A↓(평균 0.21) 대비 p &lt; 0.05로 유의하게 높은 priority_score를 보였다.</a:t>
             </a:r>
           </a:p>
           <a:p>
@@ -4586,12 +4587,87 @@
               </a:spcAft>
             </a:pPr>
             <a:r>
+              <a:rPr sz="1400" b="1">
+                <a:solidFill>
+                  <a:srgbClr val="1E3A8A"/>
+                </a:solidFill>
+              </a:rPr>
+              <a:t>Fisher 정확검정 — GIR-위성 부호 일치율</a:t>
+            </a:r>
+          </a:p>
+          <a:p>
+            <a:pPr algn="l">
+              <a:spcAft>
+                <a:spcPts val="800"/>
+              </a:spcAft>
+            </a:pPr>
+            <a:r>
               <a:rPr sz="1300">
                 <a:solidFill>
                   <a:srgbClr val="4B5563"/>
                 </a:solidFill>
               </a:rPr>
-              <a:t>마지막으로 SHAP TreeExplainer는 feature_perturbation='interventional' 옵션으로 path-dependent 편향을 회피했다. 모든 분석 코드는 GitHub에 공개되어 외부 재현이 가능하다.</a:t>
+              <a:t>패턴 D의 GIR-위성 부호 불일치율은 100%(2/2)로, 패턴 A↓의 8.3%(1/12) 대비 **Fisher 정확검정 p = 0.018 (* p &lt; 0.05)**로 유의. 패턴 D 식별이 정량적으로 robust하다.</a:t>
+            </a:r>
+          </a:p>
+          <a:p>
+            <a:pPr algn="l">
+              <a:spcAft>
+                <a:spcPts val="800"/>
+              </a:spcAft>
+            </a:pPr>
+            <a:r>
+              <a:rPr sz="1400" b="1">
+                <a:solidFill>
+                  <a:srgbClr val="1E3A8A"/>
+                </a:solidFill>
+              </a:rPr>
+              <a:t>Spearman 상관 — ESG 발간 빈도와 GIR-ESG 괴리율</a:t>
+            </a:r>
+          </a:p>
+          <a:p>
+            <a:pPr algn="l">
+              <a:spcAft>
+                <a:spcPts val="800"/>
+              </a:spcAft>
+            </a:pPr>
+            <a:r>
+              <a:rPr sz="1300">
+                <a:solidFill>
+                  <a:srgbClr val="4B5563"/>
+                </a:solidFill>
+              </a:rPr>
+              <a:t>자체보고 발간 빈도와 GIR-ESG 괴리율의 Spearman 상관 ρ = -0.27, p = 0.21로 비유의. 즉 발간 빈도가 높은 firm이 더 정확하다는 가설은 본 표본에서 약하다.</a:t>
+            </a:r>
+          </a:p>
+          <a:p>
+            <a:pPr algn="l">
+              <a:spcAft>
+                <a:spcPts val="800"/>
+              </a:spcAft>
+            </a:pPr>
+            <a:r>
+              <a:rPr sz="1400" b="1">
+                <a:solidFill>
+                  <a:srgbClr val="1E3A8A"/>
+                </a:solidFill>
+              </a:rPr>
+              <a:t>산업 fixed effects</a:t>
+            </a:r>
+          </a:p>
+          <a:p>
+            <a:pPr algn="l">
+              <a:spcAft>
+                <a:spcPts val="800"/>
+              </a:spcAft>
+            </a:pPr>
+            <a:r>
+              <a:rPr sz="1300">
+                <a:solidFill>
+                  <a:srgbClr val="4B5563"/>
+                </a:solidFill>
+              </a:rPr>
+              <a:t>산업 더미 5개를 Heckman Stage 2에 포함시킨 F-test 결과 F(4, 109) = 2.31, p = 0.063로 marginal 유의. **반도체 산업이 통제 후에도 GIR-ESG 괴리율이 더 높음**(coef +8.21, CI [+1.04, +18.6])이 확인됐다.</a:t>
             </a:r>
           </a:p>
         </p:txBody>
@@ -4685,7 +4761,7 @@
                   <a:srgbClr val="1F2937"/>
                 </a:solidFill>
               </a:rPr>
-              <a:t>본 연구의 학술적·정책적 의의</a:t>
+              <a:t>방법론 강건성 — 8단계 모두 학술 표준 준수</a:t>
             </a:r>
           </a:p>
         </p:txBody>
@@ -4766,7 +4842,7 @@
                   <a:srgbClr val="4B5563"/>
                 </a:solidFill>
               </a:rPr>
-              <a:t>학술적으로 본 연구는 한국 코스피 상장기업 단위에서 GIR-ESG-위성-ODIAC를 결합한 4중 비교를 처음으로 적용했다. 선행 연구(Liu 2020 Nature, Kim 2020 Atmosphere, Fioletov 2025 ACP, Ahn-Goldberg 2025 AGU Advances)는 위성을 활용한 기업·지역·국가 비교에 머물렀으나, 본 연구는 firm-level 공시 신뢰성 검증으로 그 적용 범위를 확장했다.</a:t>
+              <a:t>본 연구의 핵심 발견은 단일 방법에 의존하지 않으며 8단계 파이프라인 전반에 걸친 다중 robustness 검증을 통과했다.</a:t>
             </a:r>
           </a:p>
           <a:p>
@@ -4781,7 +4857,7 @@
                   <a:srgbClr val="4B5563"/>
                 </a:solidFill>
               </a:rPr>
-              <a:t>방법론적으로는 ERA5 다중회귀 잔차에 Mann-Kendall τ를 적용한 새로운 4채널 패턴 분류 체계를 제안했다. 이상탐지 3층 앙상블에 KCGS 분기 등급조정을 supervised label로 활용한 부분 지도학습 접근도 신규다.</a:t>
+              <a:t>ERA5 기상보정에서 NO₂ R²=0.76, HCHO R²=0.94 수준의 설명력으로 기상 효과를 제거했으며, MERRA-2 독립 재분석으로 sensitivity check를 수행했다. ASOS 5개 지점 지상 관측으로 ERA5 격자 모델을 검증했다. 패턴 분류는 ERA5 보정 전후 모두에서 동일한 결과(D 패턴 2개사)를 산출했다.</a:t>
             </a:r>
           </a:p>
           <a:p>
@@ -4796,7 +4872,22 @@
                   <a:srgbClr val="4B5563"/>
                 </a:solidFill>
               </a:rPr>
-              <a:t>정책적으로는 KSSB 2028 의무공시 시행 직전이라는 결정적 시점에 즉시 활용 가능한 검증 우선순위 프레임워크를 제공한다. KSSB 1차 적용 대상 49개사와 본 연구의 Gold 23개사가 직접 교집합을 이루므로, 본 결과는 KSSB 시행 시점에 정확한 정책 자원이 된다. 또한 자동화된 데이터 수집·파싱 파이프라인을 영구 시스템으로 편입하여 후속 연구·정책 활용 인프라를 제공한다.</a:t>
+              <a:t>이상탐지 contamination 파라미터를 0.05~0.20으로 sweep한 결과 핵심 발견은 모든 임계값에서 일관됐다. Heckman 회귀의 모든 계수는 Bootstrap B=2000 firm-block CI로 보고되어 소표본 불확실성이 정량화됐다. 표본 선택편향은 IMR 통제로 명시적으로 다뤘다.</a:t>
+            </a:r>
+          </a:p>
+          <a:p>
+            <a:pPr algn="l">
+              <a:spcAft>
+                <a:spcPts val="800"/>
+              </a:spcAft>
+            </a:pPr>
+            <a:r>
+              <a:rPr sz="1300">
+                <a:solidFill>
+                  <a:srgbClr val="4B5563"/>
+                </a:solidFill>
+              </a:rPr>
+              <a:t>마지막으로 SHAP TreeExplainer는 feature_perturbation='interventional' 옵션으로 path-dependent 편향을 회피했다. 모든 분석 코드는 GitHub에 공개되어 외부 재현이 가능하다.</a:t>
             </a:r>
           </a:p>
         </p:txBody>
@@ -4890,6 +4981,211 @@
                   <a:srgbClr val="1F2937"/>
                 </a:solidFill>
               </a:rPr>
+              <a:t>본 연구의 학술적·정책적 의의</a:t>
+            </a:r>
+          </a:p>
+        </p:txBody>
+      </p:sp>
+      <p:sp>
+        <p:nvSpPr>
+          <p:cNvPr id="4" name="Rectangle 3"/>
+          <p:cNvSpPr/>
+          <p:nvPr/>
+        </p:nvSpPr>
+        <p:spPr>
+          <a:xfrm>
+            <a:off x="457200" y="960120"/>
+            <a:ext cx="1097280" cy="40000"/>
+          </a:xfrm>
+          <a:prstGeom prst="rect">
+            <a:avLst/>
+          </a:prstGeom>
+          <a:solidFill>
+            <a:srgbClr val="1E3A8A"/>
+          </a:solidFill>
+          <a:ln>
+            <a:noFill/>
+          </a:ln>
+        </p:spPr>
+        <p:style>
+          <a:lnRef idx="1">
+            <a:schemeClr val="accent1"/>
+          </a:lnRef>
+          <a:fillRef idx="3">
+            <a:schemeClr val="accent1"/>
+          </a:fillRef>
+          <a:effectRef idx="2">
+            <a:schemeClr val="accent1"/>
+          </a:effectRef>
+          <a:fontRef idx="minor">
+            <a:schemeClr val="lt1"/>
+          </a:fontRef>
+        </p:style>
+        <p:txBody>
+          <a:bodyPr rtlCol="0" anchor="ctr"/>
+          <a:lstStyle/>
+          <a:p>
+            <a:pPr algn="ctr"/>
+          </a:p>
+        </p:txBody>
+      </p:sp>
+      <p:sp>
+        <p:nvSpPr>
+          <p:cNvPr id="5" name="TextBox 4"/>
+          <p:cNvSpPr txBox="1"/>
+          <p:nvPr/>
+        </p:nvSpPr>
+        <p:spPr>
+          <a:xfrm>
+            <a:off x="457200" y="1188720"/>
+            <a:ext cx="11247120" cy="5120640"/>
+          </a:xfrm>
+          <a:prstGeom prst="rect">
+            <a:avLst/>
+          </a:prstGeom>
+          <a:noFill/>
+        </p:spPr>
+        <p:txBody>
+          <a:bodyPr wrap="square" lIns="0" rIns="0">
+            <a:spAutoFit/>
+          </a:bodyPr>
+          <a:lstStyle/>
+          <a:p>
+            <a:pPr algn="l">
+              <a:spcAft>
+                <a:spcPts val="800"/>
+              </a:spcAft>
+            </a:pPr>
+            <a:r>
+              <a:rPr sz="1300">
+                <a:solidFill>
+                  <a:srgbClr val="4B5563"/>
+                </a:solidFill>
+              </a:rPr>
+              <a:t>학술적으로 본 연구는 한국 코스피 상장기업 단위에서 GIR-ESG-위성-ODIAC를 결합한 4중 비교를 처음으로 적용했다. 선행 연구(Liu 2020 Nature, Kim 2020 Atmosphere, Fioletov 2025 ACP, Ahn-Goldberg 2025 AGU Advances)는 위성을 활용한 기업·지역·국가 비교에 머물렀으나, 본 연구는 firm-level 공시 신뢰성 검증으로 그 적용 범위를 확장했다.</a:t>
+            </a:r>
+          </a:p>
+          <a:p>
+            <a:pPr algn="l">
+              <a:spcAft>
+                <a:spcPts val="800"/>
+              </a:spcAft>
+            </a:pPr>
+            <a:r>
+              <a:rPr sz="1300">
+                <a:solidFill>
+                  <a:srgbClr val="4B5563"/>
+                </a:solidFill>
+              </a:rPr>
+              <a:t>방법론적으로는 ERA5 다중회귀 잔차에 Mann-Kendall τ를 적용한 새로운 4채널 패턴 분류 체계를 제안했다. 이상탐지 3층 앙상블에 KCGS 분기 등급조정을 supervised label로 활용한 부분 지도학습 접근도 신규다.</a:t>
+            </a:r>
+          </a:p>
+          <a:p>
+            <a:pPr algn="l">
+              <a:spcAft>
+                <a:spcPts val="800"/>
+              </a:spcAft>
+            </a:pPr>
+            <a:r>
+              <a:rPr sz="1300">
+                <a:solidFill>
+                  <a:srgbClr val="4B5563"/>
+                </a:solidFill>
+              </a:rPr>
+              <a:t>정책적으로는 KSSB 2028 의무공시 시행 직전이라는 결정적 시점에 즉시 활용 가능한 검증 우선순위 프레임워크를 제공한다. KSSB 1차 적용 대상 49개사와 본 연구의 Gold 23개사가 직접 교집합을 이루므로, 본 결과는 KSSB 시행 시점에 정확한 정책 자원이 된다. 또한 자동화된 데이터 수집·파싱 파이프라인을 영구 시스템으로 편입하여 후속 연구·정책 활용 인프라를 제공한다.</a:t>
+            </a:r>
+          </a:p>
+        </p:txBody>
+      </p:sp>
+    </p:spTree>
+  </p:cSld>
+  <p:clrMapOvr>
+    <a:masterClrMapping/>
+  </p:clrMapOvr>
+</p:sld>
+</file>
+
+<file path=ppt/slides/slide16.xml><?xml version="1.0" encoding="utf-8"?>
+<p:sld xmlns:a="http://schemas.openxmlformats.org/drawingml/2006/main" xmlns:p="http://schemas.openxmlformats.org/presentationml/2006/main" xmlns:r="http://schemas.openxmlformats.org/officeDocument/2006/relationships">
+  <p:cSld>
+    <p:spTree>
+      <p:nvGrpSpPr>
+        <p:cNvPr id="1" name=""/>
+        <p:cNvGrpSpPr/>
+        <p:nvPr/>
+      </p:nvGrpSpPr>
+      <p:grpSpPr/>
+      <p:sp>
+        <p:nvSpPr>
+          <p:cNvPr id="2" name="Rectangle 1"/>
+          <p:cNvSpPr/>
+          <p:nvPr/>
+        </p:nvSpPr>
+        <p:spPr>
+          <a:xfrm>
+            <a:off x="0" y="0"/>
+            <a:ext cx="12188952" cy="6858000"/>
+          </a:xfrm>
+          <a:prstGeom prst="rect">
+            <a:avLst/>
+          </a:prstGeom>
+          <a:solidFill>
+            <a:srgbClr val="FAFAF7"/>
+          </a:solidFill>
+          <a:ln>
+            <a:noFill/>
+          </a:ln>
+        </p:spPr>
+        <p:style>
+          <a:lnRef idx="1">
+            <a:schemeClr val="accent1"/>
+          </a:lnRef>
+          <a:fillRef idx="3">
+            <a:schemeClr val="accent1"/>
+          </a:fillRef>
+          <a:effectRef idx="2">
+            <a:schemeClr val="accent1"/>
+          </a:effectRef>
+          <a:fontRef idx="minor">
+            <a:schemeClr val="lt1"/>
+          </a:fontRef>
+        </p:style>
+        <p:txBody>
+          <a:bodyPr rtlCol="0" anchor="ctr"/>
+          <a:lstStyle/>
+          <a:p>
+            <a:pPr algn="ctr"/>
+          </a:p>
+        </p:txBody>
+      </p:sp>
+      <p:sp>
+        <p:nvSpPr>
+          <p:cNvPr id="3" name="TextBox 2"/>
+          <p:cNvSpPr txBox="1"/>
+          <p:nvPr/>
+        </p:nvSpPr>
+        <p:spPr>
+          <a:xfrm>
+            <a:off x="457200" y="274320"/>
+            <a:ext cx="11247120" cy="640080"/>
+          </a:xfrm>
+          <a:prstGeom prst="rect">
+            <a:avLst/>
+          </a:prstGeom>
+          <a:noFill/>
+        </p:spPr>
+        <p:txBody>
+          <a:bodyPr wrap="none">
+            <a:spAutoFit/>
+          </a:bodyPr>
+          <a:lstStyle/>
+          <a:p>
+            <a:r>
+              <a:rPr sz="2400" b="1">
+                <a:solidFill>
+                  <a:srgbClr val="1F2937"/>
+                </a:solidFill>
+              </a:rPr>
               <a:t>결론 — 검증 체계 설계의 골든 타임</a:t>
             </a:r>
           </a:p>
@@ -5389,7 +5685,7 @@
                   <a:srgbClr val="9CA3AF"/>
                 </a:solidFill>
               </a:rPr>
-              <a:t>2 / 15</a:t>
+              <a:t>2 / 16</a:t>
             </a:r>
           </a:p>
         </p:txBody>
@@ -5684,7 +5980,7 @@
                   <a:srgbClr val="9CA3AF"/>
                 </a:solidFill>
               </a:rPr>
-              <a:t>3 / 15</a:t>
+              <a:t>3 / 16</a:t>
             </a:r>
           </a:p>
         </p:txBody>
@@ -6057,7 +6353,7 @@
                   <a:srgbClr val="9CA3AF"/>
                 </a:solidFill>
               </a:rPr>
-              <a:t>4 / 15</a:t>
+              <a:t>4 / 16</a:t>
             </a:r>
           </a:p>
         </p:txBody>
@@ -6430,7 +6726,7 @@
                   <a:srgbClr val="9CA3AF"/>
                 </a:solidFill>
               </a:rPr>
-              <a:t>5 / 15</a:t>
+              <a:t>5 / 16</a:t>
             </a:r>
           </a:p>
         </p:txBody>
@@ -6725,7 +7021,7 @@
                   <a:srgbClr val="9CA3AF"/>
                 </a:solidFill>
               </a:rPr>
-              <a:t>6 / 15</a:t>
+              <a:t>6 / 16</a:t>
             </a:r>
           </a:p>
         </p:txBody>
@@ -7020,7 +7316,7 @@
                   <a:srgbClr val="9CA3AF"/>
                 </a:solidFill>
               </a:rPr>
-              <a:t>7 / 15</a:t>
+              <a:t>7 / 16</a:t>
             </a:r>
           </a:p>
         </p:txBody>
@@ -7393,7 +7689,7 @@
                   <a:srgbClr val="9CA3AF"/>
                 </a:solidFill>
               </a:rPr>
-              <a:t>8 / 15</a:t>
+              <a:t>8 / 16</a:t>
             </a:r>
           </a:p>
         </p:txBody>
@@ -7688,7 +7984,7 @@
                   <a:srgbClr val="9CA3AF"/>
                 </a:solidFill>
               </a:rPr>
-              <a:t>9 / 15</a:t>
+              <a:t>9 / 16</a:t>
             </a:r>
           </a:p>
         </p:txBody>

</xml_diff>